<commit_message>
chore: update comprehensive_demo.pptx binary artifact
</commit_message>
<xml_diff>
--- a/comprehensive_demo.pptx
+++ b/comprehensive_demo.pptx
@@ -1450,7 +1450,9 @@
         <p:nvSpPr>
           <p:cNvPr id="2" name="Title"/>
           <p:cNvSpPr txBox="1"/>
-          <p:nvPr/>
+          <p:nvPr>
+            <p:ph type="ctrTitle"/>
+          </p:nvPr>
         </p:nvSpPr>
         <p:spPr>
           <a:xfrm>
@@ -1512,7 +1514,9 @@
         <p:nvSpPr>
           <p:cNvPr id="2" name="Title"/>
           <p:cNvSpPr txBox="1"/>
-          <p:nvPr/>
+          <p:nvPr>
+            <p:ph type="title"/>
+          </p:nvPr>
         </p:nvSpPr>
         <p:spPr>
           <a:xfrm>
@@ -1797,7 +1801,9 @@
         <p:nvSpPr>
           <p:cNvPr id="2" name="Title"/>
           <p:cNvSpPr txBox="1"/>
-          <p:nvPr/>
+          <p:nvPr>
+            <p:ph type="title"/>
+          </p:nvPr>
         </p:nvSpPr>
         <p:spPr>
           <a:xfrm>
@@ -2018,7 +2024,9 @@
         <p:nvSpPr>
           <p:cNvPr id="2" name="Title"/>
           <p:cNvSpPr txBox="1"/>
-          <p:nvPr/>
+          <p:nvPr>
+            <p:ph type="title"/>
+          </p:nvPr>
         </p:nvSpPr>
         <p:spPr>
           <a:xfrm>
@@ -2393,7 +2401,9 @@
         <p:nvSpPr>
           <p:cNvPr id="2" name="Title"/>
           <p:cNvSpPr txBox="1"/>
-          <p:nvPr/>
+          <p:nvPr>
+            <p:ph type="title"/>
+          </p:nvPr>
         </p:nvSpPr>
         <p:spPr>
           <a:xfrm>
@@ -2548,7 +2558,9 @@
         <p:nvSpPr>
           <p:cNvPr id="2" name="Title"/>
           <p:cNvSpPr txBox="1"/>
-          <p:nvPr/>
+          <p:nvPr>
+            <p:ph type="title"/>
+          </p:nvPr>
         </p:nvSpPr>
         <p:spPr>
           <a:xfrm>
@@ -2691,7 +2703,9 @@
         <p:nvSpPr>
           <p:cNvPr id="2" name="Title"/>
           <p:cNvSpPr txBox="1"/>
-          <p:nvPr/>
+          <p:nvPr>
+            <p:ph type="title"/>
+          </p:nvPr>
         </p:nvSpPr>
         <p:spPr>
           <a:xfrm>
@@ -2828,7 +2842,9 @@
         <p:nvSpPr>
           <p:cNvPr id="2" name="Title"/>
           <p:cNvSpPr txBox="1"/>
-          <p:nvPr/>
+          <p:nvPr>
+            <p:ph type="title"/>
+          </p:nvPr>
         </p:nvSpPr>
         <p:spPr>
           <a:xfrm>
@@ -2983,7 +2999,9 @@
         <p:nvSpPr>
           <p:cNvPr id="2" name="Title"/>
           <p:cNvSpPr txBox="1"/>
-          <p:nvPr/>
+          <p:nvPr>
+            <p:ph type="title"/>
+          </p:nvPr>
         </p:nvSpPr>
         <p:spPr>
           <a:xfrm>
@@ -3126,7 +3144,9 @@
         <p:nvSpPr>
           <p:cNvPr id="2" name="Title"/>
           <p:cNvSpPr txBox="1"/>
-          <p:nvPr/>
+          <p:nvPr>
+            <p:ph type="title"/>
+          </p:nvPr>
         </p:nvSpPr>
         <p:spPr>
           <a:xfrm>
@@ -3281,7 +3301,9 @@
         <p:nvSpPr>
           <p:cNvPr id="2" name="Title"/>
           <p:cNvSpPr txBox="1"/>
-          <p:nvPr/>
+          <p:nvPr>
+            <p:ph type="title"/>
+          </p:nvPr>
         </p:nvSpPr>
         <p:spPr>
           <a:xfrm>
@@ -3424,7 +3446,9 @@
         <p:nvSpPr>
           <p:cNvPr id="2" name="Title"/>
           <p:cNvSpPr txBox="1"/>
-          <p:nvPr/>
+          <p:nvPr>
+            <p:ph type="title"/>
+          </p:nvPr>
         </p:nvSpPr>
         <p:spPr>
           <a:xfrm>
@@ -3486,7 +3510,9 @@
         <p:nvSpPr>
           <p:cNvPr id="2" name="Title"/>
           <p:cNvSpPr txBox="1"/>
-          <p:nvPr/>
+          <p:nvPr>
+            <p:ph type="title"/>
+          </p:nvPr>
         </p:nvSpPr>
         <p:spPr>
           <a:xfrm>
@@ -3644,7 +3670,9 @@
         <p:nvSpPr>
           <p:cNvPr id="2" name="Title"/>
           <p:cNvSpPr txBox="1"/>
-          <p:nvPr/>
+          <p:nvPr>
+            <p:ph type="title"/>
+          </p:nvPr>
         </p:nvSpPr>
         <p:spPr>
           <a:xfrm>
@@ -4168,7 +4196,9 @@
         <p:nvSpPr>
           <p:cNvPr id="2" name="Title"/>
           <p:cNvSpPr txBox="1"/>
-          <p:nvPr/>
+          <p:nvPr>
+            <p:ph type="title"/>
+          </p:nvPr>
         </p:nvSpPr>
         <p:spPr>
           <a:xfrm>
@@ -4760,7 +4790,9 @@
         <p:nvSpPr>
           <p:cNvPr id="2" name="Title"/>
           <p:cNvSpPr txBox="1"/>
-          <p:nvPr/>
+          <p:nvPr>
+            <p:ph type="title"/>
+          </p:nvPr>
         </p:nvSpPr>
         <p:spPr>
           <a:xfrm>
@@ -5044,7 +5076,9 @@
         <p:nvSpPr>
           <p:cNvPr id="2" name="Title"/>
           <p:cNvSpPr txBox="1"/>
-          <p:nvPr/>
+          <p:nvPr>
+            <p:ph type="title"/>
+          </p:nvPr>
         </p:nvSpPr>
         <p:spPr>
           <a:xfrm>
@@ -5452,7 +5486,9 @@
         <p:nvSpPr>
           <p:cNvPr id="2" name="Title"/>
           <p:cNvSpPr txBox="1"/>
-          <p:nvPr/>
+          <p:nvPr>
+            <p:ph type="title"/>
+          </p:nvPr>
         </p:nvSpPr>
         <p:spPr>
           <a:xfrm>
@@ -5770,7 +5806,9 @@
         <p:nvSpPr>
           <p:cNvPr id="2" name="Title"/>
           <p:cNvSpPr txBox="1"/>
-          <p:nvPr/>
+          <p:nvPr>
+            <p:ph type="title"/>
+          </p:nvPr>
         </p:nvSpPr>
         <p:spPr>
           <a:xfrm>
@@ -6012,7 +6050,9 @@
         <p:nvSpPr>
           <p:cNvPr id="2" name="Title"/>
           <p:cNvSpPr txBox="1"/>
-          <p:nvPr/>
+          <p:nvPr>
+            <p:ph type="title"/>
+          </p:nvPr>
         </p:nvSpPr>
         <p:spPr>
           <a:xfrm>
@@ -6218,7 +6258,9 @@
         <p:nvSpPr>
           <p:cNvPr id="2" name="Title"/>
           <p:cNvSpPr txBox="1"/>
-          <p:nvPr/>
+          <p:nvPr>
+            <p:ph type="title"/>
+          </p:nvPr>
         </p:nvSpPr>
         <p:spPr>
           <a:xfrm>
@@ -6656,7 +6698,9 @@
         <p:nvSpPr>
           <p:cNvPr id="2" name="Title"/>
           <p:cNvSpPr txBox="1"/>
-          <p:nvPr/>
+          <p:nvPr>
+            <p:ph type="title"/>
+          </p:nvPr>
         </p:nvSpPr>
         <p:spPr>
           <a:xfrm>
@@ -6974,7 +7018,9 @@
         <p:nvSpPr>
           <p:cNvPr id="2" name="Title"/>
           <p:cNvSpPr txBox="1"/>
-          <p:nvPr/>
+          <p:nvPr>
+            <p:ph type="title"/>
+          </p:nvPr>
         </p:nvSpPr>
         <p:spPr>
           <a:xfrm>
@@ -7006,7 +7052,9 @@
         <p:nvSpPr>
           <p:cNvPr id="3" name="Content"/>
           <p:cNvSpPr txBox="1"/>
-          <p:nvPr/>
+          <p:nvPr>
+            <p:ph type="body" idx="1"/>
+          </p:nvPr>
         </p:nvSpPr>
         <p:spPr>
           <a:xfrm>
@@ -7135,7 +7183,9 @@
         <p:nvSpPr>
           <p:cNvPr id="2" name="Title"/>
           <p:cNvSpPr txBox="1"/>
-          <p:nvPr/>
+          <p:nvPr>
+            <p:ph type="title"/>
+          </p:nvPr>
         </p:nvSpPr>
         <p:spPr>
           <a:xfrm>
@@ -7167,7 +7217,9 @@
         <p:nvSpPr>
           <p:cNvPr id="3" name="Content"/>
           <p:cNvSpPr txBox="1"/>
-          <p:nvPr/>
+          <p:nvPr>
+            <p:ph type="body" idx="1"/>
+          </p:nvPr>
         </p:nvSpPr>
         <p:spPr>
           <a:xfrm>
@@ -7263,7 +7315,9 @@
         <p:nvSpPr>
           <p:cNvPr id="2" name="Title"/>
           <p:cNvSpPr txBox="1"/>
-          <p:nvPr/>
+          <p:nvPr>
+            <p:ph type="title"/>
+          </p:nvPr>
         </p:nvSpPr>
         <p:spPr>
           <a:xfrm>
@@ -7295,7 +7349,9 @@
         <p:nvSpPr>
           <p:cNvPr id="3" name="Content"/>
           <p:cNvSpPr txBox="1"/>
-          <p:nvPr/>
+          <p:nvPr>
+            <p:ph type="body" idx="1"/>
+          </p:nvPr>
         </p:nvSpPr>
         <p:spPr>
           <a:xfrm>
@@ -7382,7 +7438,9 @@
         <p:nvSpPr>
           <p:cNvPr id="2" name="Title"/>
           <p:cNvSpPr txBox="1"/>
-          <p:nvPr/>
+          <p:nvPr>
+            <p:ph type="title"/>
+          </p:nvPr>
         </p:nvSpPr>
         <p:spPr>
           <a:xfrm>
@@ -7414,7 +7472,9 @@
         <p:nvSpPr>
           <p:cNvPr id="3" name="Content"/>
           <p:cNvSpPr txBox="1"/>
-          <p:nvPr/>
+          <p:nvPr>
+            <p:ph type="body" idx="1"/>
+          </p:nvPr>
         </p:nvSpPr>
         <p:spPr>
           <a:xfrm>
@@ -7501,7 +7561,9 @@
         <p:nvSpPr>
           <p:cNvPr id="2" name="Title"/>
           <p:cNvSpPr txBox="1"/>
-          <p:nvPr/>
+          <p:nvPr>
+            <p:ph type="title"/>
+          </p:nvPr>
         </p:nvSpPr>
         <p:spPr>
           <a:xfrm>
@@ -7533,7 +7595,9 @@
         <p:nvSpPr>
           <p:cNvPr id="3" name="Content"/>
           <p:cNvSpPr txBox="1"/>
-          <p:nvPr/>
+          <p:nvPr>
+            <p:ph type="body" idx="1"/>
+          </p:nvPr>
         </p:nvSpPr>
         <p:spPr>
           <a:xfrm>
@@ -7629,7 +7693,9 @@
         <p:nvSpPr>
           <p:cNvPr id="2" name="Title"/>
           <p:cNvSpPr txBox="1"/>
-          <p:nvPr/>
+          <p:nvPr>
+            <p:ph type="title"/>
+          </p:nvPr>
         </p:nvSpPr>
         <p:spPr>
           <a:xfrm>
@@ -7661,7 +7727,9 @@
         <p:nvSpPr>
           <p:cNvPr id="3" name="Content"/>
           <p:cNvSpPr txBox="1"/>
-          <p:nvPr/>
+          <p:nvPr>
+            <p:ph type="body" idx="1"/>
+          </p:nvPr>
         </p:nvSpPr>
         <p:spPr>
           <a:xfrm>
@@ -7757,7 +7825,9 @@
         <p:nvSpPr>
           <p:cNvPr id="2" name="Title"/>
           <p:cNvSpPr txBox="1"/>
-          <p:nvPr/>
+          <p:nvPr>
+            <p:ph type="title"/>
+          </p:nvPr>
         </p:nvSpPr>
         <p:spPr>
           <a:xfrm>
@@ -7789,7 +7859,9 @@
         <p:nvSpPr>
           <p:cNvPr id="3" name="Content"/>
           <p:cNvSpPr txBox="1"/>
-          <p:nvPr/>
+          <p:nvPr>
+            <p:ph type="body" idx="1"/>
+          </p:nvPr>
         </p:nvSpPr>
         <p:spPr>
           <a:xfrm>
@@ -7903,7 +7975,9 @@
         <p:nvSpPr>
           <p:cNvPr id="2" name="Title"/>
           <p:cNvSpPr txBox="1"/>
-          <p:nvPr/>
+          <p:nvPr>
+            <p:ph type="title"/>
+          </p:nvPr>
         </p:nvSpPr>
         <p:spPr>
           <a:xfrm>
@@ -7935,7 +8009,9 @@
         <p:nvSpPr>
           <p:cNvPr id="3" name="Content"/>
           <p:cNvSpPr txBox="1"/>
-          <p:nvPr/>
+          <p:nvPr>
+            <p:ph type="body" idx="1"/>
+          </p:nvPr>
         </p:nvSpPr>
         <p:spPr>
           <a:xfrm>
@@ -8039,7 +8115,9 @@
         <p:nvSpPr>
           <p:cNvPr id="2" name="Title"/>
           <p:cNvSpPr txBox="1"/>
-          <p:nvPr/>
+          <p:nvPr>
+            <p:ph type="title"/>
+          </p:nvPr>
         </p:nvSpPr>
         <p:spPr>
           <a:xfrm>
@@ -8071,7 +8149,9 @@
         <p:nvSpPr>
           <p:cNvPr id="3" name="Content"/>
           <p:cNvSpPr txBox="1"/>
-          <p:nvPr/>
+          <p:nvPr>
+            <p:ph type="body" idx="1"/>
+          </p:nvPr>
         </p:nvSpPr>
         <p:spPr>
           <a:xfrm>
@@ -8167,7 +8247,9 @@
         <p:nvSpPr>
           <p:cNvPr id="2" name="Title"/>
           <p:cNvSpPr txBox="1"/>
-          <p:nvPr/>
+          <p:nvPr>
+            <p:ph type="title"/>
+          </p:nvPr>
         </p:nvSpPr>
         <p:spPr>
           <a:xfrm>
@@ -8481,7 +8563,9 @@
         <p:nvSpPr>
           <p:cNvPr id="2" name="Title"/>
           <p:cNvSpPr txBox="1"/>
-          <p:nvPr/>
+          <p:nvPr>
+            <p:ph type="title"/>
+          </p:nvPr>
         </p:nvSpPr>
         <p:spPr>
           <a:xfrm>
@@ -8903,7 +8987,9 @@
         <p:nvSpPr>
           <p:cNvPr id="2" name="Title"/>
           <p:cNvSpPr txBox="1"/>
-          <p:nvPr/>
+          <p:nvPr>
+            <p:ph type="title"/>
+          </p:nvPr>
         </p:nvSpPr>
         <p:spPr>
           <a:xfrm>
@@ -8935,7 +9021,9 @@
         <p:nvSpPr>
           <p:cNvPr id="3" name="Content"/>
           <p:cNvSpPr txBox="1"/>
-          <p:nvPr/>
+          <p:nvPr>
+            <p:ph type="body" idx="1"/>
+          </p:nvPr>
         </p:nvSpPr>
         <p:spPr>
           <a:xfrm>
@@ -9013,7 +9101,9 @@
         <p:nvSpPr>
           <p:cNvPr id="2" name="Title"/>
           <p:cNvSpPr txBox="1"/>
-          <p:nvPr/>
+          <p:nvPr>
+            <p:ph type="title"/>
+          </p:nvPr>
         </p:nvSpPr>
         <p:spPr>
           <a:xfrm>
@@ -9045,7 +9135,9 @@
         <p:nvSpPr>
           <p:cNvPr id="3" name="Content"/>
           <p:cNvSpPr txBox="1"/>
-          <p:nvPr/>
+          <p:nvPr>
+            <p:ph type="body" idx="1"/>
+          </p:nvPr>
         </p:nvSpPr>
         <p:spPr>
           <a:xfrm>
@@ -9141,7 +9233,9 @@
         <p:nvSpPr>
           <p:cNvPr id="2" name="Title"/>
           <p:cNvSpPr txBox="1"/>
-          <p:nvPr/>
+          <p:nvPr>
+            <p:ph type="title"/>
+          </p:nvPr>
         </p:nvSpPr>
         <p:spPr>
           <a:xfrm>
@@ -9173,7 +9267,9 @@
         <p:nvSpPr>
           <p:cNvPr id="3" name="Content"/>
           <p:cNvSpPr txBox="1"/>
-          <p:nvPr/>
+          <p:nvPr>
+            <p:ph type="body" idx="1"/>
+          </p:nvPr>
         </p:nvSpPr>
         <p:spPr>
           <a:xfrm>
@@ -9287,7 +9383,9 @@
         <p:nvSpPr>
           <p:cNvPr id="2" name="Title"/>
           <p:cNvSpPr txBox="1"/>
-          <p:nvPr/>
+          <p:nvPr>
+            <p:ph type="title"/>
+          </p:nvPr>
         </p:nvSpPr>
         <p:spPr>
           <a:xfrm>
@@ -9998,7 +10096,9 @@
         <p:nvSpPr>
           <p:cNvPr id="2" name="Title"/>
           <p:cNvSpPr txBox="1"/>
-          <p:nvPr/>
+          <p:nvPr>
+            <p:ph type="title"/>
+          </p:nvPr>
         </p:nvSpPr>
         <p:spPr>
           <a:xfrm>
@@ -10658,7 +10758,9 @@
         <p:nvSpPr>
           <p:cNvPr id="2" name="Title"/>
           <p:cNvSpPr txBox="1"/>
-          <p:nvPr/>
+          <p:nvPr>
+            <p:ph type="title"/>
+          </p:nvPr>
         </p:nvSpPr>
         <p:spPr>
           <a:xfrm>
@@ -11272,7 +11374,9 @@
         <p:nvSpPr>
           <p:cNvPr id="2" name="Title"/>
           <p:cNvSpPr txBox="1"/>
-          <p:nvPr/>
+          <p:nvPr>
+            <p:ph type="title"/>
+          </p:nvPr>
         </p:nvSpPr>
         <p:spPr>
           <a:xfrm>
@@ -11304,7 +11408,9 @@
         <p:nvSpPr>
           <p:cNvPr id="3" name="Left Content"/>
           <p:cNvSpPr txBox="1"/>
-          <p:nvPr/>
+          <p:nvPr>
+            <p:ph type="body" idx="1"/>
+          </p:nvPr>
         </p:nvSpPr>
         <p:spPr>
           <a:xfrm>
@@ -11352,7 +11458,9 @@
         <p:nvSpPr>
           <p:cNvPr id="4" name="Right Content"/>
           <p:cNvSpPr txBox="1"/>
-          <p:nvPr/>
+          <p:nvPr>
+            <p:ph type="body" idx="2"/>
+          </p:nvPr>
         </p:nvSpPr>
         <p:spPr>
           <a:xfrm>
@@ -11460,7 +11568,9 @@
         <p:nvSpPr>
           <p:cNvPr id="2" name="Title"/>
           <p:cNvSpPr txBox="1"/>
-          <p:nvPr/>
+          <p:nvPr>
+            <p:ph type="title"/>
+          </p:nvPr>
         </p:nvSpPr>
         <p:spPr>
           <a:xfrm>
@@ -11779,7 +11889,9 @@
         <p:nvSpPr>
           <p:cNvPr id="2" name="Title"/>
           <p:cNvSpPr txBox="1"/>
-          <p:nvPr/>
+          <p:nvPr>
+            <p:ph type="title"/>
+          </p:nvPr>
         </p:nvSpPr>
         <p:spPr>
           <a:xfrm>
@@ -11811,7 +11923,9 @@
         <p:nvSpPr>
           <p:cNvPr id="3" name="Content"/>
           <p:cNvSpPr txBox="1"/>
-          <p:nvPr/>
+          <p:nvPr>
+            <p:ph type="body" idx="1"/>
+          </p:nvPr>
         </p:nvSpPr>
         <p:spPr>
           <a:xfrm>
@@ -11889,7 +12003,9 @@
         <p:nvSpPr>
           <p:cNvPr id="2" name="Title"/>
           <p:cNvSpPr txBox="1"/>
-          <p:nvPr/>
+          <p:nvPr>
+            <p:ph type="title"/>
+          </p:nvPr>
         </p:nvSpPr>
         <p:spPr>
           <a:xfrm>

</xml_diff>